<commit_message>
Adição de 2 placeholders novos
</commit_message>
<xml_diff>
--- a/simulador_duofitness/templates/duo.pptx
+++ b/simulador_duofitness/templates/duo.pptx
@@ -343,7 +343,7 @@
             <a:fld id="{1D8BD707-D9CF-40AE-B4C6-C98DA3205C09}" type="datetimeFigureOut">
               <a:rPr lang="en-US" smtClean="0"/>
               <a:pPr/>
-              <a:t>6/26/2026</a:t>
+              <a:t>6/30/2026</a:t>
             </a:fld>
             <a:endParaRPr lang="en-US"/>
           </a:p>
@@ -508,7 +508,7 @@
             <a:fld id="{1D8BD707-D9CF-40AE-B4C6-C98DA3205C09}" type="datetimeFigureOut">
               <a:rPr lang="en-US" smtClean="0"/>
               <a:pPr/>
-              <a:t>6/26/2026</a:t>
+              <a:t>6/30/2026</a:t>
             </a:fld>
             <a:endParaRPr lang="en-US"/>
           </a:p>
@@ -683,7 +683,7 @@
             <a:fld id="{1D8BD707-D9CF-40AE-B4C6-C98DA3205C09}" type="datetimeFigureOut">
               <a:rPr lang="en-US" smtClean="0"/>
               <a:pPr/>
-              <a:t>6/26/2026</a:t>
+              <a:t>6/30/2026</a:t>
             </a:fld>
             <a:endParaRPr lang="en-US"/>
           </a:p>
@@ -848,7 +848,7 @@
             <a:fld id="{1D8BD707-D9CF-40AE-B4C6-C98DA3205C09}" type="datetimeFigureOut">
               <a:rPr lang="en-US" smtClean="0"/>
               <a:pPr/>
-              <a:t>6/26/2026</a:t>
+              <a:t>6/30/2026</a:t>
             </a:fld>
             <a:endParaRPr lang="en-US"/>
           </a:p>
@@ -1090,7 +1090,7 @@
             <a:fld id="{1D8BD707-D9CF-40AE-B4C6-C98DA3205C09}" type="datetimeFigureOut">
               <a:rPr lang="en-US" smtClean="0"/>
               <a:pPr/>
-              <a:t>6/26/2026</a:t>
+              <a:t>6/30/2026</a:t>
             </a:fld>
             <a:endParaRPr lang="en-US"/>
           </a:p>
@@ -1372,7 +1372,7 @@
             <a:fld id="{1D8BD707-D9CF-40AE-B4C6-C98DA3205C09}" type="datetimeFigureOut">
               <a:rPr lang="en-US" smtClean="0"/>
               <a:pPr/>
-              <a:t>6/26/2026</a:t>
+              <a:t>6/30/2026</a:t>
             </a:fld>
             <a:endParaRPr lang="en-US"/>
           </a:p>
@@ -1788,7 +1788,7 @@
             <a:fld id="{1D8BD707-D9CF-40AE-B4C6-C98DA3205C09}" type="datetimeFigureOut">
               <a:rPr lang="en-US" smtClean="0"/>
               <a:pPr/>
-              <a:t>6/26/2026</a:t>
+              <a:t>6/30/2026</a:t>
             </a:fld>
             <a:endParaRPr lang="en-US"/>
           </a:p>
@@ -1902,7 +1902,7 @@
             <a:fld id="{1D8BD707-D9CF-40AE-B4C6-C98DA3205C09}" type="datetimeFigureOut">
               <a:rPr lang="en-US" smtClean="0"/>
               <a:pPr/>
-              <a:t>6/26/2026</a:t>
+              <a:t>6/30/2026</a:t>
             </a:fld>
             <a:endParaRPr lang="en-US"/>
           </a:p>
@@ -1994,7 +1994,7 @@
             <a:fld id="{1D8BD707-D9CF-40AE-B4C6-C98DA3205C09}" type="datetimeFigureOut">
               <a:rPr lang="en-US" smtClean="0"/>
               <a:pPr/>
-              <a:t>6/26/2026</a:t>
+              <a:t>6/30/2026</a:t>
             </a:fld>
             <a:endParaRPr lang="en-US"/>
           </a:p>
@@ -2266,7 +2266,7 @@
             <a:fld id="{1D8BD707-D9CF-40AE-B4C6-C98DA3205C09}" type="datetimeFigureOut">
               <a:rPr lang="en-US" smtClean="0"/>
               <a:pPr/>
-              <a:t>6/26/2026</a:t>
+              <a:t>6/30/2026</a:t>
             </a:fld>
             <a:endParaRPr lang="en-US"/>
           </a:p>
@@ -2515,7 +2515,7 @@
             <a:fld id="{1D8BD707-D9CF-40AE-B4C6-C98DA3205C09}" type="datetimeFigureOut">
               <a:rPr lang="en-US" smtClean="0"/>
               <a:pPr/>
-              <a:t>6/26/2026</a:t>
+              <a:t>6/30/2026</a:t>
             </a:fld>
             <a:endParaRPr lang="en-US"/>
           </a:p>
@@ -2723,7 +2723,7 @@
             <a:fld id="{1D8BD707-D9CF-40AE-B4C6-C98DA3205C09}" type="datetimeFigureOut">
               <a:rPr lang="en-US" smtClean="0"/>
               <a:pPr/>
-              <a:t>6/26/2026</a:t>
+              <a:t>6/30/2026</a:t>
             </a:fld>
             <a:endParaRPr lang="en-US"/>
           </a:p>
@@ -9646,7 +9646,7 @@
         </p:nvGrpSpPr>
         <p:grpSpPr>
           <a:xfrm>
-            <a:off x="9677048" y="6286689"/>
+            <a:off x="9677048" y="7810500"/>
             <a:ext cx="6611142" cy="685611"/>
             <a:chOff x="0" y="0"/>
             <a:chExt cx="1741206" cy="180572"/>
@@ -9872,7 +9872,7 @@
         <p:spPr>
           <a:xfrm>
             <a:off x="9863310" y="2085223"/>
-            <a:ext cx="7395990" cy="5927392"/>
+            <a:ext cx="7395990" cy="7517571"/>
           </a:xfrm>
           <a:prstGeom prst="rect">
             <a:avLst/>
@@ -10114,6 +10114,129 @@
                 <a:sym typeface="Open Sans Bold Italics"/>
               </a:rPr>
               <a:t>: [PRAZO]</a:t>
+            </a:r>
+          </a:p>
+          <a:p>
+            <a:pPr algn="l">
+              <a:lnSpc>
+                <a:spcPts val="3067"/>
+              </a:lnSpc>
+              <a:spcBef>
+                <a:spcPct val="0"/>
+              </a:spcBef>
+            </a:pPr>
+            <a:endParaRPr lang="en-US" sz="2190" b="1" i="1" dirty="0">
+              <a:solidFill>
+                <a:srgbClr val="FFD300"/>
+              </a:solidFill>
+              <a:latin typeface="Open Sans Bold Italics"/>
+              <a:ea typeface="Open Sans Bold Italics"/>
+              <a:cs typeface="Open Sans Bold Italics"/>
+              <a:sym typeface="Open Sans Bold Italics"/>
+            </a:endParaRPr>
+          </a:p>
+          <a:p>
+            <a:pPr algn="l">
+              <a:lnSpc>
+                <a:spcPts val="3067"/>
+              </a:lnSpc>
+              <a:spcBef>
+                <a:spcPct val="0"/>
+              </a:spcBef>
+            </a:pPr>
+            <a:r>
+              <a:rPr lang="en-US" sz="2190" b="1" i="1" dirty="0" err="1">
+                <a:solidFill>
+                  <a:srgbClr val="FFD300"/>
+                </a:solidFill>
+                <a:latin typeface="Open Sans Bold Italics"/>
+                <a:ea typeface="Open Sans Bold Italics"/>
+                <a:cs typeface="Open Sans Bold Italics"/>
+                <a:sym typeface="Open Sans Bold Italics"/>
+              </a:rPr>
+              <a:t>Período</a:t>
+            </a:r>
+            <a:r>
+              <a:rPr lang="en-US" sz="2190" b="1" i="1" dirty="0">
+                <a:solidFill>
+                  <a:srgbClr val="FFD300"/>
+                </a:solidFill>
+                <a:latin typeface="Open Sans Bold Italics"/>
+                <a:ea typeface="Open Sans Bold Italics"/>
+                <a:cs typeface="Open Sans Bold Italics"/>
+                <a:sym typeface="Open Sans Bold Italics"/>
+              </a:rPr>
+              <a:t> </a:t>
+            </a:r>
+            <a:r>
+              <a:rPr lang="en-US" sz="2190" b="1" i="1" dirty="0" err="1">
+                <a:solidFill>
+                  <a:srgbClr val="FFD300"/>
+                </a:solidFill>
+                <a:latin typeface="Open Sans Bold Italics"/>
+                <a:ea typeface="Open Sans Bold Italics"/>
+                <a:cs typeface="Open Sans Bold Italics"/>
+                <a:sym typeface="Open Sans Bold Italics"/>
+              </a:rPr>
+              <a:t>Promocional</a:t>
+            </a:r>
+            <a:r>
+              <a:rPr lang="en-US" sz="2190" b="1" i="1" dirty="0">
+                <a:solidFill>
+                  <a:srgbClr val="FFD300"/>
+                </a:solidFill>
+                <a:latin typeface="Open Sans Bold Italics"/>
+                <a:ea typeface="Open Sans Bold Italics"/>
+                <a:cs typeface="Open Sans Bold Italics"/>
+                <a:sym typeface="Open Sans Bold Italics"/>
+              </a:rPr>
+              <a:t>:</a:t>
+            </a:r>
+            <a:br>
+              <a:rPr lang="en-US" sz="2190" b="1" i="1" dirty="0">
+                <a:solidFill>
+                  <a:srgbClr val="FFD300"/>
+                </a:solidFill>
+                <a:latin typeface="Open Sans Bold Italics"/>
+                <a:ea typeface="Open Sans Bold Italics"/>
+                <a:cs typeface="Open Sans Bold Italics"/>
+                <a:sym typeface="Open Sans Bold Italics"/>
+              </a:rPr>
+            </a:br>
+            <a:r>
+              <a:rPr lang="en-US" sz="2190" b="1" i="1" dirty="0">
+                <a:solidFill>
+                  <a:srgbClr val="FFD300"/>
+                </a:solidFill>
+                <a:latin typeface="Open Sans Bold Italics"/>
+                <a:ea typeface="Open Sans Bold Italics"/>
+                <a:cs typeface="Open Sans Bold Italics"/>
+                <a:sym typeface="Open Sans Bold Italics"/>
+              </a:rPr>
+              <a:t>- [PROMO_MES]</a:t>
+            </a:r>
+            <a:br>
+              <a:rPr lang="en-US" sz="2190" b="1" i="1" dirty="0">
+                <a:solidFill>
+                  <a:srgbClr val="FFD300"/>
+                </a:solidFill>
+                <a:latin typeface="Open Sans Bold Italics"/>
+                <a:ea typeface="Open Sans Bold Italics"/>
+                <a:cs typeface="Open Sans Bold Italics"/>
+                <a:sym typeface="Open Sans Bold Italics"/>
+              </a:rPr>
+            </a:br>
+            <a:r>
+              <a:rPr lang="en-US" sz="2190" b="1" i="1" dirty="0">
+                <a:solidFill>
+                  <a:srgbClr val="FFD300"/>
+                </a:solidFill>
+                <a:latin typeface="Open Sans Bold Italics"/>
+                <a:ea typeface="Open Sans Bold Italics"/>
+                <a:cs typeface="Open Sans Bold Italics"/>
+                <a:sym typeface="Open Sans Bold Italics"/>
+              </a:rPr>
+              <a:t>- [PROMO_VALOR]</a:t>
             </a:r>
           </a:p>
           <a:p>

</xml_diff>